<commit_message>
Actualizar materiales y agregar README con información del proyecto
</commit_message>
<xml_diff>
--- a/Presentaciones/IA_Matroneria_Parte_2.pptx
+++ b/Presentaciones/IA_Matroneria_Parte_2.pptx
@@ -5883,7 +5883,22 @@
                   <a:srgbClr val="06717E"/>
                 </a:solidFill>
               </a:rPr>
-              <a:t>Títulos y Grados.​</a:t>
+              <a:t>Matrona Especialista en Neonatología, Máster en enfermería neonatal.</a:t>
+            </a:r>
+            <a:br>
+              <a:rPr lang="es-CL" sz="1200" dirty="0">
+                <a:solidFill>
+                  <a:srgbClr val="06717E"/>
+                </a:solidFill>
+              </a:rPr>
+            </a:br>
+            <a:r>
+              <a:rPr lang="es-CL" sz="1200" dirty="0">
+                <a:solidFill>
+                  <a:srgbClr val="06717E"/>
+                </a:solidFill>
+              </a:rPr>
+              <a:t>Académica Escuela de Obstetricia y Puericultura. Dpto. Salud Fetal y Neonatal​</a:t>
             </a:r>
           </a:p>
         </p:txBody>
@@ -32371,6 +32386,15 @@
 </file>
 
 <file path=customXml/item1.xml><?xml version="1.0" encoding="utf-8"?>
+<?mso-contentType ?>
+<FormTemplates xmlns="http://schemas.microsoft.com/sharepoint/v3/contenttype/forms">
+  <Display>DocumentLibraryForm</Display>
+  <Edit>DocumentLibraryForm</Edit>
+  <New>DocumentLibraryForm</New>
+</FormTemplates>
+</file>
+
+<file path=customXml/item2.xml><?xml version="1.0" encoding="utf-8"?>
 <p:properties xmlns:p="http://schemas.microsoft.com/office/2006/metadata/properties" xmlns:xsi="http://www.w3.org/2001/XMLSchema-instance" xmlns:pc="http://schemas.microsoft.com/office/infopath/2007/PartnerControls">
   <documentManagement>
     <TaxCatchAll xmlns="39f852db-6116-43f0-a01a-f747f551a9b7" xsi:nil="true"/>
@@ -32379,15 +32403,6 @@
     </lcf76f155ced4ddcb4097134ff3c332f>
   </documentManagement>
 </p:properties>
-</file>
-
-<file path=customXml/item2.xml><?xml version="1.0" encoding="utf-8"?>
-<?mso-contentType ?>
-<FormTemplates xmlns="http://schemas.microsoft.com/sharepoint/v3/contenttype/forms">
-  <Display>DocumentLibraryForm</Display>
-  <Edit>DocumentLibraryForm</Edit>
-  <New>DocumentLibraryForm</New>
-</FormTemplates>
 </file>
 
 <file path=customXml/item3.xml><?xml version="1.0" encoding="utf-8"?>
@@ -32640,6 +32655,14 @@
 </file>
 
 <file path=customXml/itemProps1.xml><?xml version="1.0" encoding="utf-8"?>
+<ds:datastoreItem xmlns:ds="http://schemas.openxmlformats.org/officeDocument/2006/customXml" ds:itemID="{B6FF4F38-7A2A-471E-A58C-16BD05A1D01B}">
+  <ds:schemaRefs>
+    <ds:schemaRef ds:uri="http://schemas.microsoft.com/sharepoint/v3/contenttype/forms"/>
+  </ds:schemaRefs>
+</ds:datastoreItem>
+</file>
+
+<file path=customXml/itemProps2.xml><?xml version="1.0" encoding="utf-8"?>
 <ds:datastoreItem xmlns:ds="http://schemas.openxmlformats.org/officeDocument/2006/customXml" ds:itemID="{F864ECA2-A753-4D45-B299-F9626E461873}">
   <ds:schemaRefs>
     <ds:schemaRef ds:uri="58e3b983-b9c9-4a9a-8434-0fe099e73c0e"/>
@@ -32652,14 +32675,6 @@
     <ds:schemaRef ds:uri="39f852db-6116-43f0-a01a-f747f551a9b7"/>
     <ds:schemaRef ds:uri="http://schemas.microsoft.com/office/2006/metadata/properties"/>
     <ds:schemaRef ds:uri="http://www.w3.org/XML/1998/namespace"/>
-  </ds:schemaRefs>
-</ds:datastoreItem>
-</file>
-
-<file path=customXml/itemProps2.xml><?xml version="1.0" encoding="utf-8"?>
-<ds:datastoreItem xmlns:ds="http://schemas.openxmlformats.org/officeDocument/2006/customXml" ds:itemID="{B6FF4F38-7A2A-471E-A58C-16BD05A1D01B}">
-  <ds:schemaRefs>
-    <ds:schemaRef ds:uri="http://schemas.microsoft.com/sharepoint/v3/contenttype/forms"/>
   </ds:schemaRefs>
 </ds:datastoreItem>
 </file>

</xml_diff>